<commit_message>
Project Document and Presentation
</commit_message>
<xml_diff>
--- a/Project Presentation.pptx
+++ b/Project Presentation.pptx
@@ -11,8 +11,11 @@
     <p:sldId id="258" r:id="rId5"/>
     <p:sldId id="266" r:id="rId6"/>
     <p:sldId id="268" r:id="rId7"/>
-    <p:sldId id="265" r:id="rId8"/>
-    <p:sldId id="267" r:id="rId9"/>
+    <p:sldId id="270" r:id="rId8"/>
+    <p:sldId id="271" r:id="rId9"/>
+    <p:sldId id="269" r:id="rId10"/>
+    <p:sldId id="265" r:id="rId11"/>
+    <p:sldId id="267" r:id="rId12"/>
   </p:sldIdLst>
   <p:sldSz cx="12192000" cy="6858000"/>
   <p:notesSz cx="6858000" cy="9144000"/>
@@ -3543,6 +3546,759 @@
 </p:sld>
 </file>
 
+<file path=ppt/slides/slide10.xml><?xml version="1.0" encoding="utf-8"?>
+<p:sld xmlns:a="http://schemas.openxmlformats.org/drawingml/2006/main" xmlns:r="http://schemas.openxmlformats.org/officeDocument/2006/relationships" xmlns:p="http://schemas.openxmlformats.org/presentationml/2006/main">
+  <p:cSld>
+    <p:spTree>
+      <p:nvGrpSpPr>
+        <p:cNvPr id="1" name=""/>
+        <p:cNvGrpSpPr/>
+        <p:nvPr/>
+      </p:nvGrpSpPr>
+      <p:grpSpPr>
+        <a:xfrm>
+          <a:off x="0" y="0"/>
+          <a:ext cx="0" cy="0"/>
+          <a:chOff x="0" y="0"/>
+          <a:chExt cx="0" cy="0"/>
+        </a:xfrm>
+      </p:grpSpPr>
+      <p:sp>
+        <p:nvSpPr>
+          <p:cNvPr id="2" name="TextBox 1"/>
+          <p:cNvSpPr txBox="1"/>
+          <p:nvPr/>
+        </p:nvSpPr>
+        <p:spPr>
+          <a:xfrm>
+            <a:off x="738556" y="1661745"/>
+            <a:ext cx="11139854" cy="2739211"/>
+          </a:xfrm>
+          <a:prstGeom prst="rect">
+            <a:avLst/>
+          </a:prstGeom>
+          <a:noFill/>
+        </p:spPr>
+        <p:txBody>
+          <a:bodyPr wrap="square" rtlCol="0">
+            <a:spAutoFit/>
+          </a:bodyPr>
+          <a:lstStyle/>
+          <a:p>
+            <a:r>
+              <a:rPr lang="en-IN" sz="2800" dirty="0" smtClean="0">
+                <a:solidFill>
+                  <a:schemeClr val="bg2">
+                    <a:lumMod val="75000"/>
+                  </a:schemeClr>
+                </a:solidFill>
+              </a:rPr>
+              <a:t>Objectives for Milestone 3:</a:t>
+            </a:r>
+            <a:endParaRPr lang="en-IN" dirty="0" smtClean="0">
+              <a:solidFill>
+                <a:schemeClr val="bg2">
+                  <a:lumMod val="75000"/>
+                </a:schemeClr>
+              </a:solidFill>
+            </a:endParaRPr>
+          </a:p>
+          <a:p>
+            <a:endParaRPr lang="en-IN" dirty="0"/>
+          </a:p>
+          <a:p>
+            <a:pPr marL="285750" indent="-285750">
+              <a:buFont typeface="Arial" panose="020B0604020202020204" pitchFamily="34" charset="0"/>
+              <a:buChar char="•"/>
+            </a:pPr>
+            <a:r>
+              <a:rPr lang="en-IN" dirty="0"/>
+              <a:t>Implement </a:t>
+            </a:r>
+            <a:r>
+              <a:rPr lang="en-IN" dirty="0" smtClean="0"/>
+              <a:t>Backend using Python and connect it to frontend</a:t>
+            </a:r>
+            <a:endParaRPr lang="en-IN" dirty="0"/>
+          </a:p>
+          <a:p>
+            <a:pPr marL="285750" indent="-285750">
+              <a:buFont typeface="Arial" panose="020B0604020202020204" pitchFamily="34" charset="0"/>
+              <a:buChar char="•"/>
+            </a:pPr>
+            <a:endParaRPr lang="en-US" dirty="0"/>
+          </a:p>
+          <a:p>
+            <a:pPr marL="285750" indent="-285750">
+              <a:buFont typeface="Arial" panose="020B0604020202020204" pitchFamily="34" charset="0"/>
+              <a:buChar char="•"/>
+            </a:pPr>
+            <a:r>
+              <a:rPr lang="en-US" dirty="0" smtClean="0"/>
+              <a:t>Improve UI responsiveness</a:t>
+            </a:r>
+          </a:p>
+          <a:p>
+            <a:pPr marL="285750" indent="-285750">
+              <a:buFont typeface="Arial" panose="020B0604020202020204" pitchFamily="34" charset="0"/>
+              <a:buChar char="•"/>
+            </a:pPr>
+            <a:endParaRPr lang="en-US" dirty="0"/>
+          </a:p>
+          <a:p>
+            <a:pPr marL="285750" indent="-285750">
+              <a:buFont typeface="Arial" panose="020B0604020202020204" pitchFamily="34" charset="0"/>
+              <a:buChar char="•"/>
+            </a:pPr>
+            <a:r>
+              <a:rPr lang="en-US" dirty="0" smtClean="0"/>
+              <a:t>Integrate a </a:t>
+            </a:r>
+            <a:r>
+              <a:rPr lang="en-US" dirty="0" err="1" smtClean="0"/>
+              <a:t>chatbot</a:t>
+            </a:r>
+            <a:r>
+              <a:rPr lang="en-US" dirty="0" smtClean="0"/>
+              <a:t> in UI</a:t>
+            </a:r>
+          </a:p>
+          <a:p>
+            <a:pPr marL="285750" indent="-285750">
+              <a:buFont typeface="Arial" panose="020B0604020202020204" pitchFamily="34" charset="0"/>
+              <a:buChar char="•"/>
+            </a:pPr>
+            <a:endParaRPr lang="en-US" dirty="0"/>
+          </a:p>
+          <a:p>
+            <a:pPr marL="285750" indent="-285750">
+              <a:buFont typeface="Arial" panose="020B0604020202020204" pitchFamily="34" charset="0"/>
+              <a:buChar char="•"/>
+            </a:pPr>
+            <a:r>
+              <a:rPr lang="en-US" dirty="0" smtClean="0"/>
+              <a:t>Integrate a weather agent</a:t>
+            </a:r>
+            <a:endParaRPr lang="en-IN" dirty="0"/>
+          </a:p>
+        </p:txBody>
+      </p:sp>
+    </p:spTree>
+    <p:extLst>
+      <p:ext uri="{BB962C8B-B14F-4D97-AF65-F5344CB8AC3E}">
+        <p14:creationId xmlns:p14="http://schemas.microsoft.com/office/powerpoint/2010/main" val="215316"/>
+      </p:ext>
+    </p:extLst>
+  </p:cSld>
+  <p:clrMapOvr>
+    <a:masterClrMapping/>
+  </p:clrMapOvr>
+  <p:timing>
+    <p:tnLst>
+      <p:par>
+        <p:cTn id="1" dur="indefinite" restart="never" nodeType="tmRoot">
+          <p:childTnLst>
+            <p:seq concurrent="1" nextAc="seek">
+              <p:cTn id="2" dur="indefinite" nodeType="mainSeq">
+                <p:childTnLst>
+                  <p:par>
+                    <p:cTn id="3" fill="hold">
+                      <p:stCondLst>
+                        <p:cond delay="indefinite"/>
+                      </p:stCondLst>
+                      <p:childTnLst>
+                        <p:par>
+                          <p:cTn id="4" fill="hold">
+                            <p:stCondLst>
+                              <p:cond delay="0"/>
+                            </p:stCondLst>
+                            <p:childTnLst>
+                              <p:par>
+                                <p:cTn id="5" presetID="53" presetClass="entr" presetSubtype="16" fill="hold" nodeType="clickEffect">
+                                  <p:stCondLst>
+                                    <p:cond delay="0"/>
+                                  </p:stCondLst>
+                                  <p:childTnLst>
+                                    <p:set>
+                                      <p:cBhvr>
+                                        <p:cTn id="6" dur="1" fill="hold">
+                                          <p:stCondLst>
+                                            <p:cond delay="0"/>
+                                          </p:stCondLst>
+                                        </p:cTn>
+                                        <p:tgtEl>
+                                          <p:spTgt spid="2">
+                                            <p:txEl>
+                                              <p:pRg st="0" end="0"/>
+                                            </p:txEl>
+                                          </p:spTgt>
+                                        </p:tgtEl>
+                                        <p:attrNameLst>
+                                          <p:attrName>style.visibility</p:attrName>
+                                        </p:attrNameLst>
+                                      </p:cBhvr>
+                                      <p:to>
+                                        <p:strVal val="visible"/>
+                                      </p:to>
+                                    </p:set>
+                                    <p:anim calcmode="lin" valueType="num">
+                                      <p:cBhvr>
+                                        <p:cTn id="7" dur="500" fill="hold"/>
+                                        <p:tgtEl>
+                                          <p:spTgt spid="2">
+                                            <p:txEl>
+                                              <p:pRg st="0" end="0"/>
+                                            </p:txEl>
+                                          </p:spTgt>
+                                        </p:tgtEl>
+                                        <p:attrNameLst>
+                                          <p:attrName>ppt_w</p:attrName>
+                                        </p:attrNameLst>
+                                      </p:cBhvr>
+                                      <p:tavLst>
+                                        <p:tav tm="0">
+                                          <p:val>
+                                            <p:fltVal val="0"/>
+                                          </p:val>
+                                        </p:tav>
+                                        <p:tav tm="100000">
+                                          <p:val>
+                                            <p:strVal val="#ppt_w"/>
+                                          </p:val>
+                                        </p:tav>
+                                      </p:tavLst>
+                                    </p:anim>
+                                    <p:anim calcmode="lin" valueType="num">
+                                      <p:cBhvr>
+                                        <p:cTn id="8" dur="500" fill="hold"/>
+                                        <p:tgtEl>
+                                          <p:spTgt spid="2">
+                                            <p:txEl>
+                                              <p:pRg st="0" end="0"/>
+                                            </p:txEl>
+                                          </p:spTgt>
+                                        </p:tgtEl>
+                                        <p:attrNameLst>
+                                          <p:attrName>ppt_h</p:attrName>
+                                        </p:attrNameLst>
+                                      </p:cBhvr>
+                                      <p:tavLst>
+                                        <p:tav tm="0">
+                                          <p:val>
+                                            <p:fltVal val="0"/>
+                                          </p:val>
+                                        </p:tav>
+                                        <p:tav tm="100000">
+                                          <p:val>
+                                            <p:strVal val="#ppt_h"/>
+                                          </p:val>
+                                        </p:tav>
+                                      </p:tavLst>
+                                    </p:anim>
+                                    <p:animEffect transition="in" filter="fade">
+                                      <p:cBhvr>
+                                        <p:cTn id="9" dur="500"/>
+                                        <p:tgtEl>
+                                          <p:spTgt spid="2">
+                                            <p:txEl>
+                                              <p:pRg st="0" end="0"/>
+                                            </p:txEl>
+                                          </p:spTgt>
+                                        </p:tgtEl>
+                                      </p:cBhvr>
+                                    </p:animEffect>
+                                  </p:childTnLst>
+                                </p:cTn>
+                              </p:par>
+                              <p:par>
+                                <p:cTn id="10" presetID="53" presetClass="entr" presetSubtype="16" fill="hold" nodeType="withEffect">
+                                  <p:stCondLst>
+                                    <p:cond delay="0"/>
+                                  </p:stCondLst>
+                                  <p:childTnLst>
+                                    <p:set>
+                                      <p:cBhvr>
+                                        <p:cTn id="11" dur="1" fill="hold">
+                                          <p:stCondLst>
+                                            <p:cond delay="0"/>
+                                          </p:stCondLst>
+                                        </p:cTn>
+                                        <p:tgtEl>
+                                          <p:spTgt spid="2">
+                                            <p:txEl>
+                                              <p:pRg st="2" end="2"/>
+                                            </p:txEl>
+                                          </p:spTgt>
+                                        </p:tgtEl>
+                                        <p:attrNameLst>
+                                          <p:attrName>style.visibility</p:attrName>
+                                        </p:attrNameLst>
+                                      </p:cBhvr>
+                                      <p:to>
+                                        <p:strVal val="visible"/>
+                                      </p:to>
+                                    </p:set>
+                                    <p:anim calcmode="lin" valueType="num">
+                                      <p:cBhvr>
+                                        <p:cTn id="12" dur="500" fill="hold"/>
+                                        <p:tgtEl>
+                                          <p:spTgt spid="2">
+                                            <p:txEl>
+                                              <p:pRg st="2" end="2"/>
+                                            </p:txEl>
+                                          </p:spTgt>
+                                        </p:tgtEl>
+                                        <p:attrNameLst>
+                                          <p:attrName>ppt_w</p:attrName>
+                                        </p:attrNameLst>
+                                      </p:cBhvr>
+                                      <p:tavLst>
+                                        <p:tav tm="0">
+                                          <p:val>
+                                            <p:fltVal val="0"/>
+                                          </p:val>
+                                        </p:tav>
+                                        <p:tav tm="100000">
+                                          <p:val>
+                                            <p:strVal val="#ppt_w"/>
+                                          </p:val>
+                                        </p:tav>
+                                      </p:tavLst>
+                                    </p:anim>
+                                    <p:anim calcmode="lin" valueType="num">
+                                      <p:cBhvr>
+                                        <p:cTn id="13" dur="500" fill="hold"/>
+                                        <p:tgtEl>
+                                          <p:spTgt spid="2">
+                                            <p:txEl>
+                                              <p:pRg st="2" end="2"/>
+                                            </p:txEl>
+                                          </p:spTgt>
+                                        </p:tgtEl>
+                                        <p:attrNameLst>
+                                          <p:attrName>ppt_h</p:attrName>
+                                        </p:attrNameLst>
+                                      </p:cBhvr>
+                                      <p:tavLst>
+                                        <p:tav tm="0">
+                                          <p:val>
+                                            <p:fltVal val="0"/>
+                                          </p:val>
+                                        </p:tav>
+                                        <p:tav tm="100000">
+                                          <p:val>
+                                            <p:strVal val="#ppt_h"/>
+                                          </p:val>
+                                        </p:tav>
+                                      </p:tavLst>
+                                    </p:anim>
+                                    <p:animEffect transition="in" filter="fade">
+                                      <p:cBhvr>
+                                        <p:cTn id="14" dur="500"/>
+                                        <p:tgtEl>
+                                          <p:spTgt spid="2">
+                                            <p:txEl>
+                                              <p:pRg st="2" end="2"/>
+                                            </p:txEl>
+                                          </p:spTgt>
+                                        </p:tgtEl>
+                                      </p:cBhvr>
+                                    </p:animEffect>
+                                  </p:childTnLst>
+                                </p:cTn>
+                              </p:par>
+                              <p:par>
+                                <p:cTn id="15" presetID="53" presetClass="entr" presetSubtype="16" fill="hold" nodeType="withEffect">
+                                  <p:stCondLst>
+                                    <p:cond delay="0"/>
+                                  </p:stCondLst>
+                                  <p:childTnLst>
+                                    <p:set>
+                                      <p:cBhvr>
+                                        <p:cTn id="16" dur="1" fill="hold">
+                                          <p:stCondLst>
+                                            <p:cond delay="0"/>
+                                          </p:stCondLst>
+                                        </p:cTn>
+                                        <p:tgtEl>
+                                          <p:spTgt spid="2">
+                                            <p:txEl>
+                                              <p:pRg st="4" end="4"/>
+                                            </p:txEl>
+                                          </p:spTgt>
+                                        </p:tgtEl>
+                                        <p:attrNameLst>
+                                          <p:attrName>style.visibility</p:attrName>
+                                        </p:attrNameLst>
+                                      </p:cBhvr>
+                                      <p:to>
+                                        <p:strVal val="visible"/>
+                                      </p:to>
+                                    </p:set>
+                                    <p:anim calcmode="lin" valueType="num">
+                                      <p:cBhvr>
+                                        <p:cTn id="17" dur="500" fill="hold"/>
+                                        <p:tgtEl>
+                                          <p:spTgt spid="2">
+                                            <p:txEl>
+                                              <p:pRg st="4" end="4"/>
+                                            </p:txEl>
+                                          </p:spTgt>
+                                        </p:tgtEl>
+                                        <p:attrNameLst>
+                                          <p:attrName>ppt_w</p:attrName>
+                                        </p:attrNameLst>
+                                      </p:cBhvr>
+                                      <p:tavLst>
+                                        <p:tav tm="0">
+                                          <p:val>
+                                            <p:fltVal val="0"/>
+                                          </p:val>
+                                        </p:tav>
+                                        <p:tav tm="100000">
+                                          <p:val>
+                                            <p:strVal val="#ppt_w"/>
+                                          </p:val>
+                                        </p:tav>
+                                      </p:tavLst>
+                                    </p:anim>
+                                    <p:anim calcmode="lin" valueType="num">
+                                      <p:cBhvr>
+                                        <p:cTn id="18" dur="500" fill="hold"/>
+                                        <p:tgtEl>
+                                          <p:spTgt spid="2">
+                                            <p:txEl>
+                                              <p:pRg st="4" end="4"/>
+                                            </p:txEl>
+                                          </p:spTgt>
+                                        </p:tgtEl>
+                                        <p:attrNameLst>
+                                          <p:attrName>ppt_h</p:attrName>
+                                        </p:attrNameLst>
+                                      </p:cBhvr>
+                                      <p:tavLst>
+                                        <p:tav tm="0">
+                                          <p:val>
+                                            <p:fltVal val="0"/>
+                                          </p:val>
+                                        </p:tav>
+                                        <p:tav tm="100000">
+                                          <p:val>
+                                            <p:strVal val="#ppt_h"/>
+                                          </p:val>
+                                        </p:tav>
+                                      </p:tavLst>
+                                    </p:anim>
+                                    <p:animEffect transition="in" filter="fade">
+                                      <p:cBhvr>
+                                        <p:cTn id="19" dur="500"/>
+                                        <p:tgtEl>
+                                          <p:spTgt spid="2">
+                                            <p:txEl>
+                                              <p:pRg st="4" end="4"/>
+                                            </p:txEl>
+                                          </p:spTgt>
+                                        </p:tgtEl>
+                                      </p:cBhvr>
+                                    </p:animEffect>
+                                  </p:childTnLst>
+                                </p:cTn>
+                              </p:par>
+                              <p:par>
+                                <p:cTn id="20" presetID="53" presetClass="entr" presetSubtype="16" fill="hold" nodeType="withEffect">
+                                  <p:stCondLst>
+                                    <p:cond delay="0"/>
+                                  </p:stCondLst>
+                                  <p:childTnLst>
+                                    <p:set>
+                                      <p:cBhvr>
+                                        <p:cTn id="21" dur="1" fill="hold">
+                                          <p:stCondLst>
+                                            <p:cond delay="0"/>
+                                          </p:stCondLst>
+                                        </p:cTn>
+                                        <p:tgtEl>
+                                          <p:spTgt spid="2">
+                                            <p:txEl>
+                                              <p:pRg st="6" end="6"/>
+                                            </p:txEl>
+                                          </p:spTgt>
+                                        </p:tgtEl>
+                                        <p:attrNameLst>
+                                          <p:attrName>style.visibility</p:attrName>
+                                        </p:attrNameLst>
+                                      </p:cBhvr>
+                                      <p:to>
+                                        <p:strVal val="visible"/>
+                                      </p:to>
+                                    </p:set>
+                                    <p:anim calcmode="lin" valueType="num">
+                                      <p:cBhvr>
+                                        <p:cTn id="22" dur="500" fill="hold"/>
+                                        <p:tgtEl>
+                                          <p:spTgt spid="2">
+                                            <p:txEl>
+                                              <p:pRg st="6" end="6"/>
+                                            </p:txEl>
+                                          </p:spTgt>
+                                        </p:tgtEl>
+                                        <p:attrNameLst>
+                                          <p:attrName>ppt_w</p:attrName>
+                                        </p:attrNameLst>
+                                      </p:cBhvr>
+                                      <p:tavLst>
+                                        <p:tav tm="0">
+                                          <p:val>
+                                            <p:fltVal val="0"/>
+                                          </p:val>
+                                        </p:tav>
+                                        <p:tav tm="100000">
+                                          <p:val>
+                                            <p:strVal val="#ppt_w"/>
+                                          </p:val>
+                                        </p:tav>
+                                      </p:tavLst>
+                                    </p:anim>
+                                    <p:anim calcmode="lin" valueType="num">
+                                      <p:cBhvr>
+                                        <p:cTn id="23" dur="500" fill="hold"/>
+                                        <p:tgtEl>
+                                          <p:spTgt spid="2">
+                                            <p:txEl>
+                                              <p:pRg st="6" end="6"/>
+                                            </p:txEl>
+                                          </p:spTgt>
+                                        </p:tgtEl>
+                                        <p:attrNameLst>
+                                          <p:attrName>ppt_h</p:attrName>
+                                        </p:attrNameLst>
+                                      </p:cBhvr>
+                                      <p:tavLst>
+                                        <p:tav tm="0">
+                                          <p:val>
+                                            <p:fltVal val="0"/>
+                                          </p:val>
+                                        </p:tav>
+                                        <p:tav tm="100000">
+                                          <p:val>
+                                            <p:strVal val="#ppt_h"/>
+                                          </p:val>
+                                        </p:tav>
+                                      </p:tavLst>
+                                    </p:anim>
+                                    <p:animEffect transition="in" filter="fade">
+                                      <p:cBhvr>
+                                        <p:cTn id="24" dur="500"/>
+                                        <p:tgtEl>
+                                          <p:spTgt spid="2">
+                                            <p:txEl>
+                                              <p:pRg st="6" end="6"/>
+                                            </p:txEl>
+                                          </p:spTgt>
+                                        </p:tgtEl>
+                                      </p:cBhvr>
+                                    </p:animEffect>
+                                  </p:childTnLst>
+                                </p:cTn>
+                              </p:par>
+                              <p:par>
+                                <p:cTn id="25" presetID="53" presetClass="entr" presetSubtype="16" fill="hold" nodeType="withEffect">
+                                  <p:stCondLst>
+                                    <p:cond delay="0"/>
+                                  </p:stCondLst>
+                                  <p:childTnLst>
+                                    <p:set>
+                                      <p:cBhvr>
+                                        <p:cTn id="26" dur="1" fill="hold">
+                                          <p:stCondLst>
+                                            <p:cond delay="0"/>
+                                          </p:stCondLst>
+                                        </p:cTn>
+                                        <p:tgtEl>
+                                          <p:spTgt spid="2">
+                                            <p:txEl>
+                                              <p:pRg st="8" end="8"/>
+                                            </p:txEl>
+                                          </p:spTgt>
+                                        </p:tgtEl>
+                                        <p:attrNameLst>
+                                          <p:attrName>style.visibility</p:attrName>
+                                        </p:attrNameLst>
+                                      </p:cBhvr>
+                                      <p:to>
+                                        <p:strVal val="visible"/>
+                                      </p:to>
+                                    </p:set>
+                                    <p:anim calcmode="lin" valueType="num">
+                                      <p:cBhvr>
+                                        <p:cTn id="27" dur="500" fill="hold"/>
+                                        <p:tgtEl>
+                                          <p:spTgt spid="2">
+                                            <p:txEl>
+                                              <p:pRg st="8" end="8"/>
+                                            </p:txEl>
+                                          </p:spTgt>
+                                        </p:tgtEl>
+                                        <p:attrNameLst>
+                                          <p:attrName>ppt_w</p:attrName>
+                                        </p:attrNameLst>
+                                      </p:cBhvr>
+                                      <p:tavLst>
+                                        <p:tav tm="0">
+                                          <p:val>
+                                            <p:fltVal val="0"/>
+                                          </p:val>
+                                        </p:tav>
+                                        <p:tav tm="100000">
+                                          <p:val>
+                                            <p:strVal val="#ppt_w"/>
+                                          </p:val>
+                                        </p:tav>
+                                      </p:tavLst>
+                                    </p:anim>
+                                    <p:anim calcmode="lin" valueType="num">
+                                      <p:cBhvr>
+                                        <p:cTn id="28" dur="500" fill="hold"/>
+                                        <p:tgtEl>
+                                          <p:spTgt spid="2">
+                                            <p:txEl>
+                                              <p:pRg st="8" end="8"/>
+                                            </p:txEl>
+                                          </p:spTgt>
+                                        </p:tgtEl>
+                                        <p:attrNameLst>
+                                          <p:attrName>ppt_h</p:attrName>
+                                        </p:attrNameLst>
+                                      </p:cBhvr>
+                                      <p:tavLst>
+                                        <p:tav tm="0">
+                                          <p:val>
+                                            <p:fltVal val="0"/>
+                                          </p:val>
+                                        </p:tav>
+                                        <p:tav tm="100000">
+                                          <p:val>
+                                            <p:strVal val="#ppt_h"/>
+                                          </p:val>
+                                        </p:tav>
+                                      </p:tavLst>
+                                    </p:anim>
+                                    <p:animEffect transition="in" filter="fade">
+                                      <p:cBhvr>
+                                        <p:cTn id="29" dur="500"/>
+                                        <p:tgtEl>
+                                          <p:spTgt spid="2">
+                                            <p:txEl>
+                                              <p:pRg st="8" end="8"/>
+                                            </p:txEl>
+                                          </p:spTgt>
+                                        </p:tgtEl>
+                                      </p:cBhvr>
+                                    </p:animEffect>
+                                  </p:childTnLst>
+                                </p:cTn>
+                              </p:par>
+                            </p:childTnLst>
+                          </p:cTn>
+                        </p:par>
+                      </p:childTnLst>
+                    </p:cTn>
+                  </p:par>
+                </p:childTnLst>
+              </p:cTn>
+              <p:prevCondLst>
+                <p:cond evt="onPrev" delay="0">
+                  <p:tgtEl>
+                    <p:sldTgt/>
+                  </p:tgtEl>
+                </p:cond>
+              </p:prevCondLst>
+              <p:nextCondLst>
+                <p:cond evt="onNext" delay="0">
+                  <p:tgtEl>
+                    <p:sldTgt/>
+                  </p:tgtEl>
+                </p:cond>
+              </p:nextCondLst>
+            </p:seq>
+          </p:childTnLst>
+        </p:cTn>
+      </p:par>
+    </p:tnLst>
+  </p:timing>
+</p:sld>
+</file>
+
+<file path=ppt/slides/slide11.xml><?xml version="1.0" encoding="utf-8"?>
+<p:sld xmlns:a="http://schemas.openxmlformats.org/drawingml/2006/main" xmlns:r="http://schemas.openxmlformats.org/officeDocument/2006/relationships" xmlns:p="http://schemas.openxmlformats.org/presentationml/2006/main">
+  <p:cSld>
+    <p:spTree>
+      <p:nvGrpSpPr>
+        <p:cNvPr id="1" name=""/>
+        <p:cNvGrpSpPr/>
+        <p:nvPr/>
+      </p:nvGrpSpPr>
+      <p:grpSpPr>
+        <a:xfrm>
+          <a:off x="0" y="0"/>
+          <a:ext cx="0" cy="0"/>
+          <a:chOff x="0" y="0"/>
+          <a:chExt cx="0" cy="0"/>
+        </a:xfrm>
+      </p:grpSpPr>
+      <p:sp>
+        <p:nvSpPr>
+          <p:cNvPr id="2" name="TextBox 1"/>
+          <p:cNvSpPr txBox="1"/>
+          <p:nvPr/>
+        </p:nvSpPr>
+        <p:spPr>
+          <a:xfrm>
+            <a:off x="2637692" y="1907931"/>
+            <a:ext cx="7728438" cy="1569660"/>
+          </a:xfrm>
+          <a:prstGeom prst="rect">
+            <a:avLst/>
+          </a:prstGeom>
+          <a:noFill/>
+        </p:spPr>
+        <p:txBody>
+          <a:bodyPr wrap="square" rtlCol="0">
+            <a:spAutoFit/>
+          </a:bodyPr>
+          <a:lstStyle/>
+          <a:p>
+            <a:r>
+              <a:rPr lang="en-US" sz="9600" dirty="0" smtClean="0"/>
+              <a:t>THANK YOU</a:t>
+            </a:r>
+            <a:endParaRPr lang="en-IN" sz="9600" dirty="0"/>
+          </a:p>
+        </p:txBody>
+      </p:sp>
+    </p:spTree>
+    <p:extLst>
+      <p:ext uri="{BB962C8B-B14F-4D97-AF65-F5344CB8AC3E}">
+        <p14:creationId xmlns:p14="http://schemas.microsoft.com/office/powerpoint/2010/main" val="2833710442"/>
+      </p:ext>
+    </p:extLst>
+  </p:cSld>
+  <p:clrMapOvr>
+    <a:masterClrMapping/>
+  </p:clrMapOvr>
+  <p:transition spd="slow">
+    <p:wipe/>
+  </p:transition>
+  <p:timing>
+    <p:tnLst>
+      <p:par>
+        <p:cTn id="1" dur="indefinite" restart="never" nodeType="tmRoot"/>
+      </p:par>
+    </p:tnLst>
+  </p:timing>
+</p:sld>
+</file>
+
 <file path=ppt/slides/slide2.xml><?xml version="1.0" encoding="utf-8"?>
 <p:sld xmlns:a="http://schemas.openxmlformats.org/drawingml/2006/main" xmlns:r="http://schemas.openxmlformats.org/officeDocument/2006/relationships" xmlns:p="http://schemas.openxmlformats.org/presentationml/2006/main">
   <p:cSld>
@@ -6306,12 +7062,17 @@
             </a:pPr>
             <a:r>
               <a:rPr lang="en-US" dirty="0" smtClean="0"/>
-              <a:t>Used to train Machine Learning models and Deep Learning models to predict air </a:t>
-            </a:r>
-            <a:r>
-              <a:rPr lang="en-US" dirty="0" smtClean="0"/>
-              <a:t>quality, creating the backend for the project and connecting to the database.</a:t>
-            </a:r>
+              <a:t>Used to train Machine Learning models and Deep Learning models to predict </a:t>
+            </a:r>
+            <a:r>
+              <a:rPr lang="en-US" smtClean="0"/>
+              <a:t>air </a:t>
+            </a:r>
+            <a:r>
+              <a:rPr lang="en-US" smtClean="0"/>
+              <a:t>quality.</a:t>
+            </a:r>
+            <a:endParaRPr lang="en-US" dirty="0" smtClean="0"/>
           </a:p>
           <a:p>
             <a:pPr marL="285750" indent="-285750">
@@ -6368,7 +7129,6 @@
               <a:rPr lang="en-US" dirty="0" smtClean="0"/>
               <a:t>Used to train LSTM model.</a:t>
             </a:r>
-            <a:endParaRPr lang="en-US" dirty="0" smtClean="0"/>
           </a:p>
         </p:txBody>
       </p:sp>
@@ -6797,673 +7557,110 @@
           <a:chExt cx="0" cy="0"/>
         </a:xfrm>
       </p:grpSpPr>
-      <p:sp>
-        <p:nvSpPr>
-          <p:cNvPr id="2" name="TextBox 1"/>
-          <p:cNvSpPr txBox="1"/>
+      <p:pic>
+        <p:nvPicPr>
+          <p:cNvPr id="2" name="Picture 1"/>
+          <p:cNvPicPr>
+            <a:picLocks noChangeAspect="1"/>
+          </p:cNvPicPr>
           <p:nvPr/>
-        </p:nvSpPr>
+        </p:nvPicPr>
+        <p:blipFill>
+          <a:blip r:embed="rId2">
+            <a:extLst>
+              <a:ext uri="{28A0092B-C50C-407E-A947-70E740481C1C}">
+                <a14:useLocalDpi xmlns:a14="http://schemas.microsoft.com/office/drawing/2010/main" val="0"/>
+              </a:ext>
+            </a:extLst>
+          </a:blip>
+          <a:stretch>
+            <a:fillRect/>
+          </a:stretch>
+        </p:blipFill>
         <p:spPr>
           <a:xfrm>
-            <a:off x="738556" y="1661745"/>
-            <a:ext cx="11139854" cy="2739211"/>
+            <a:off x="0" y="0"/>
+            <a:ext cx="12192000" cy="6858000"/>
           </a:xfrm>
           <a:prstGeom prst="rect">
             <a:avLst/>
           </a:prstGeom>
-          <a:noFill/>
         </p:spPr>
-        <p:txBody>
-          <a:bodyPr wrap="square" rtlCol="0">
-            <a:spAutoFit/>
-          </a:bodyPr>
-          <a:lstStyle/>
-          <a:p>
-            <a:r>
-              <a:rPr lang="en-IN" sz="2800" dirty="0" smtClean="0">
-                <a:solidFill>
-                  <a:schemeClr val="bg2">
-                    <a:lumMod val="75000"/>
-                  </a:schemeClr>
-                </a:solidFill>
-              </a:rPr>
-              <a:t>Objectives for Milestone 3:</a:t>
-            </a:r>
-            <a:endParaRPr lang="en-IN" dirty="0" smtClean="0">
-              <a:solidFill>
-                <a:schemeClr val="bg2">
-                  <a:lumMod val="75000"/>
-                </a:schemeClr>
-              </a:solidFill>
-            </a:endParaRPr>
-          </a:p>
-          <a:p>
-            <a:endParaRPr lang="en-IN" dirty="0"/>
-          </a:p>
-          <a:p>
-            <a:pPr marL="285750" indent="-285750">
-              <a:buFont typeface="Arial" panose="020B0604020202020204" pitchFamily="34" charset="0"/>
-              <a:buChar char="•"/>
-            </a:pPr>
-            <a:r>
-              <a:rPr lang="en-IN" dirty="0"/>
-              <a:t>Implement </a:t>
-            </a:r>
-            <a:r>
-              <a:rPr lang="en-IN" dirty="0" smtClean="0"/>
-              <a:t>Backend using Python and connect it to frontend</a:t>
-            </a:r>
-            <a:endParaRPr lang="en-IN" dirty="0"/>
-          </a:p>
-          <a:p>
-            <a:pPr marL="285750" indent="-285750">
-              <a:buFont typeface="Arial" panose="020B0604020202020204" pitchFamily="34" charset="0"/>
-              <a:buChar char="•"/>
-            </a:pPr>
-            <a:endParaRPr lang="en-US" dirty="0"/>
-          </a:p>
-          <a:p>
-            <a:pPr marL="285750" indent="-285750">
-              <a:buFont typeface="Arial" panose="020B0604020202020204" pitchFamily="34" charset="0"/>
-              <a:buChar char="•"/>
-            </a:pPr>
-            <a:r>
-              <a:rPr lang="en-US" dirty="0" smtClean="0"/>
-              <a:t>Improve UI responsiveness</a:t>
-            </a:r>
-          </a:p>
-          <a:p>
-            <a:pPr marL="285750" indent="-285750">
-              <a:buFont typeface="Arial" panose="020B0604020202020204" pitchFamily="34" charset="0"/>
-              <a:buChar char="•"/>
-            </a:pPr>
-            <a:endParaRPr lang="en-US" dirty="0"/>
-          </a:p>
-          <a:p>
-            <a:pPr marL="285750" indent="-285750">
-              <a:buFont typeface="Arial" panose="020B0604020202020204" pitchFamily="34" charset="0"/>
-              <a:buChar char="•"/>
-            </a:pPr>
-            <a:r>
-              <a:rPr lang="en-US" dirty="0" smtClean="0"/>
-              <a:t>Integrate a </a:t>
-            </a:r>
-            <a:r>
-              <a:rPr lang="en-US" dirty="0" err="1" smtClean="0"/>
-              <a:t>chatbot</a:t>
-            </a:r>
-            <a:r>
-              <a:rPr lang="en-US" dirty="0" smtClean="0"/>
-              <a:t> in UI</a:t>
-            </a:r>
-          </a:p>
-          <a:p>
-            <a:pPr marL="285750" indent="-285750">
-              <a:buFont typeface="Arial" panose="020B0604020202020204" pitchFamily="34" charset="0"/>
-              <a:buChar char="•"/>
-            </a:pPr>
-            <a:endParaRPr lang="en-US" dirty="0"/>
-          </a:p>
-          <a:p>
-            <a:pPr marL="285750" indent="-285750">
-              <a:buFont typeface="Arial" panose="020B0604020202020204" pitchFamily="34" charset="0"/>
-              <a:buChar char="•"/>
-            </a:pPr>
-            <a:r>
-              <a:rPr lang="en-US" dirty="0" smtClean="0"/>
-              <a:t>Integrate a weather agent</a:t>
-            </a:r>
-            <a:endParaRPr lang="en-IN" dirty="0"/>
-          </a:p>
-        </p:txBody>
-      </p:sp>
+      </p:pic>
     </p:spTree>
     <p:extLst>
       <p:ext uri="{BB962C8B-B14F-4D97-AF65-F5344CB8AC3E}">
-        <p14:creationId xmlns:p14="http://schemas.microsoft.com/office/powerpoint/2010/main" val="215316"/>
+        <p14:creationId xmlns:p14="http://schemas.microsoft.com/office/powerpoint/2010/main" val="1421526065"/>
       </p:ext>
     </p:extLst>
   </p:cSld>
   <p:clrMapOvr>
     <a:masterClrMapping/>
   </p:clrMapOvr>
-  <p:timing>
-    <p:tnLst>
-      <p:par>
-        <p:cTn id="1" dur="indefinite" restart="never" nodeType="tmRoot">
-          <p:childTnLst>
-            <p:seq concurrent="1" nextAc="seek">
-              <p:cTn id="2" dur="indefinite" nodeType="mainSeq">
-                <p:childTnLst>
-                  <p:par>
-                    <p:cTn id="3" fill="hold">
-                      <p:stCondLst>
-                        <p:cond delay="indefinite"/>
-                      </p:stCondLst>
-                      <p:childTnLst>
-                        <p:par>
-                          <p:cTn id="4" fill="hold">
-                            <p:stCondLst>
-                              <p:cond delay="0"/>
-                            </p:stCondLst>
-                            <p:childTnLst>
-                              <p:par>
-                                <p:cTn id="5" presetID="53" presetClass="entr" presetSubtype="16" fill="hold" nodeType="clickEffect">
-                                  <p:stCondLst>
-                                    <p:cond delay="0"/>
-                                  </p:stCondLst>
-                                  <p:childTnLst>
-                                    <p:set>
-                                      <p:cBhvr>
-                                        <p:cTn id="6" dur="1" fill="hold">
-                                          <p:stCondLst>
-                                            <p:cond delay="0"/>
-                                          </p:stCondLst>
-                                        </p:cTn>
-                                        <p:tgtEl>
-                                          <p:spTgt spid="2">
-                                            <p:txEl>
-                                              <p:pRg st="0" end="0"/>
-                                            </p:txEl>
-                                          </p:spTgt>
-                                        </p:tgtEl>
-                                        <p:attrNameLst>
-                                          <p:attrName>style.visibility</p:attrName>
-                                        </p:attrNameLst>
-                                      </p:cBhvr>
-                                      <p:to>
-                                        <p:strVal val="visible"/>
-                                      </p:to>
-                                    </p:set>
-                                    <p:anim calcmode="lin" valueType="num">
-                                      <p:cBhvr>
-                                        <p:cTn id="7" dur="500" fill="hold"/>
-                                        <p:tgtEl>
-                                          <p:spTgt spid="2">
-                                            <p:txEl>
-                                              <p:pRg st="0" end="0"/>
-                                            </p:txEl>
-                                          </p:spTgt>
-                                        </p:tgtEl>
-                                        <p:attrNameLst>
-                                          <p:attrName>ppt_w</p:attrName>
-                                        </p:attrNameLst>
-                                      </p:cBhvr>
-                                      <p:tavLst>
-                                        <p:tav tm="0">
-                                          <p:val>
-                                            <p:fltVal val="0"/>
-                                          </p:val>
-                                        </p:tav>
-                                        <p:tav tm="100000">
-                                          <p:val>
-                                            <p:strVal val="#ppt_w"/>
-                                          </p:val>
-                                        </p:tav>
-                                      </p:tavLst>
-                                    </p:anim>
-                                    <p:anim calcmode="lin" valueType="num">
-                                      <p:cBhvr>
-                                        <p:cTn id="8" dur="500" fill="hold"/>
-                                        <p:tgtEl>
-                                          <p:spTgt spid="2">
-                                            <p:txEl>
-                                              <p:pRg st="0" end="0"/>
-                                            </p:txEl>
-                                          </p:spTgt>
-                                        </p:tgtEl>
-                                        <p:attrNameLst>
-                                          <p:attrName>ppt_h</p:attrName>
-                                        </p:attrNameLst>
-                                      </p:cBhvr>
-                                      <p:tavLst>
-                                        <p:tav tm="0">
-                                          <p:val>
-                                            <p:fltVal val="0"/>
-                                          </p:val>
-                                        </p:tav>
-                                        <p:tav tm="100000">
-                                          <p:val>
-                                            <p:strVal val="#ppt_h"/>
-                                          </p:val>
-                                        </p:tav>
-                                      </p:tavLst>
-                                    </p:anim>
-                                    <p:animEffect transition="in" filter="fade">
-                                      <p:cBhvr>
-                                        <p:cTn id="9" dur="500"/>
-                                        <p:tgtEl>
-                                          <p:spTgt spid="2">
-                                            <p:txEl>
-                                              <p:pRg st="0" end="0"/>
-                                            </p:txEl>
-                                          </p:spTgt>
-                                        </p:tgtEl>
-                                      </p:cBhvr>
-                                    </p:animEffect>
-                                  </p:childTnLst>
-                                </p:cTn>
-                              </p:par>
-                              <p:par>
-                                <p:cTn id="10" presetID="53" presetClass="entr" presetSubtype="16" fill="hold" nodeType="withEffect">
-                                  <p:stCondLst>
-                                    <p:cond delay="0"/>
-                                  </p:stCondLst>
-                                  <p:childTnLst>
-                                    <p:set>
-                                      <p:cBhvr>
-                                        <p:cTn id="11" dur="1" fill="hold">
-                                          <p:stCondLst>
-                                            <p:cond delay="0"/>
-                                          </p:stCondLst>
-                                        </p:cTn>
-                                        <p:tgtEl>
-                                          <p:spTgt spid="2">
-                                            <p:txEl>
-                                              <p:pRg st="2" end="2"/>
-                                            </p:txEl>
-                                          </p:spTgt>
-                                        </p:tgtEl>
-                                        <p:attrNameLst>
-                                          <p:attrName>style.visibility</p:attrName>
-                                        </p:attrNameLst>
-                                      </p:cBhvr>
-                                      <p:to>
-                                        <p:strVal val="visible"/>
-                                      </p:to>
-                                    </p:set>
-                                    <p:anim calcmode="lin" valueType="num">
-                                      <p:cBhvr>
-                                        <p:cTn id="12" dur="500" fill="hold"/>
-                                        <p:tgtEl>
-                                          <p:spTgt spid="2">
-                                            <p:txEl>
-                                              <p:pRg st="2" end="2"/>
-                                            </p:txEl>
-                                          </p:spTgt>
-                                        </p:tgtEl>
-                                        <p:attrNameLst>
-                                          <p:attrName>ppt_w</p:attrName>
-                                        </p:attrNameLst>
-                                      </p:cBhvr>
-                                      <p:tavLst>
-                                        <p:tav tm="0">
-                                          <p:val>
-                                            <p:fltVal val="0"/>
-                                          </p:val>
-                                        </p:tav>
-                                        <p:tav tm="100000">
-                                          <p:val>
-                                            <p:strVal val="#ppt_w"/>
-                                          </p:val>
-                                        </p:tav>
-                                      </p:tavLst>
-                                    </p:anim>
-                                    <p:anim calcmode="lin" valueType="num">
-                                      <p:cBhvr>
-                                        <p:cTn id="13" dur="500" fill="hold"/>
-                                        <p:tgtEl>
-                                          <p:spTgt spid="2">
-                                            <p:txEl>
-                                              <p:pRg st="2" end="2"/>
-                                            </p:txEl>
-                                          </p:spTgt>
-                                        </p:tgtEl>
-                                        <p:attrNameLst>
-                                          <p:attrName>ppt_h</p:attrName>
-                                        </p:attrNameLst>
-                                      </p:cBhvr>
-                                      <p:tavLst>
-                                        <p:tav tm="0">
-                                          <p:val>
-                                            <p:fltVal val="0"/>
-                                          </p:val>
-                                        </p:tav>
-                                        <p:tav tm="100000">
-                                          <p:val>
-                                            <p:strVal val="#ppt_h"/>
-                                          </p:val>
-                                        </p:tav>
-                                      </p:tavLst>
-                                    </p:anim>
-                                    <p:animEffect transition="in" filter="fade">
-                                      <p:cBhvr>
-                                        <p:cTn id="14" dur="500"/>
-                                        <p:tgtEl>
-                                          <p:spTgt spid="2">
-                                            <p:txEl>
-                                              <p:pRg st="2" end="2"/>
-                                            </p:txEl>
-                                          </p:spTgt>
-                                        </p:tgtEl>
-                                      </p:cBhvr>
-                                    </p:animEffect>
-                                  </p:childTnLst>
-                                </p:cTn>
-                              </p:par>
-                              <p:par>
-                                <p:cTn id="15" presetID="53" presetClass="entr" presetSubtype="16" fill="hold" nodeType="withEffect">
-                                  <p:stCondLst>
-                                    <p:cond delay="0"/>
-                                  </p:stCondLst>
-                                  <p:childTnLst>
-                                    <p:set>
-                                      <p:cBhvr>
-                                        <p:cTn id="16" dur="1" fill="hold">
-                                          <p:stCondLst>
-                                            <p:cond delay="0"/>
-                                          </p:stCondLst>
-                                        </p:cTn>
-                                        <p:tgtEl>
-                                          <p:spTgt spid="2">
-                                            <p:txEl>
-                                              <p:pRg st="4" end="4"/>
-                                            </p:txEl>
-                                          </p:spTgt>
-                                        </p:tgtEl>
-                                        <p:attrNameLst>
-                                          <p:attrName>style.visibility</p:attrName>
-                                        </p:attrNameLst>
-                                      </p:cBhvr>
-                                      <p:to>
-                                        <p:strVal val="visible"/>
-                                      </p:to>
-                                    </p:set>
-                                    <p:anim calcmode="lin" valueType="num">
-                                      <p:cBhvr>
-                                        <p:cTn id="17" dur="500" fill="hold"/>
-                                        <p:tgtEl>
-                                          <p:spTgt spid="2">
-                                            <p:txEl>
-                                              <p:pRg st="4" end="4"/>
-                                            </p:txEl>
-                                          </p:spTgt>
-                                        </p:tgtEl>
-                                        <p:attrNameLst>
-                                          <p:attrName>ppt_w</p:attrName>
-                                        </p:attrNameLst>
-                                      </p:cBhvr>
-                                      <p:tavLst>
-                                        <p:tav tm="0">
-                                          <p:val>
-                                            <p:fltVal val="0"/>
-                                          </p:val>
-                                        </p:tav>
-                                        <p:tav tm="100000">
-                                          <p:val>
-                                            <p:strVal val="#ppt_w"/>
-                                          </p:val>
-                                        </p:tav>
-                                      </p:tavLst>
-                                    </p:anim>
-                                    <p:anim calcmode="lin" valueType="num">
-                                      <p:cBhvr>
-                                        <p:cTn id="18" dur="500" fill="hold"/>
-                                        <p:tgtEl>
-                                          <p:spTgt spid="2">
-                                            <p:txEl>
-                                              <p:pRg st="4" end="4"/>
-                                            </p:txEl>
-                                          </p:spTgt>
-                                        </p:tgtEl>
-                                        <p:attrNameLst>
-                                          <p:attrName>ppt_h</p:attrName>
-                                        </p:attrNameLst>
-                                      </p:cBhvr>
-                                      <p:tavLst>
-                                        <p:tav tm="0">
-                                          <p:val>
-                                            <p:fltVal val="0"/>
-                                          </p:val>
-                                        </p:tav>
-                                        <p:tav tm="100000">
-                                          <p:val>
-                                            <p:strVal val="#ppt_h"/>
-                                          </p:val>
-                                        </p:tav>
-                                      </p:tavLst>
-                                    </p:anim>
-                                    <p:animEffect transition="in" filter="fade">
-                                      <p:cBhvr>
-                                        <p:cTn id="19" dur="500"/>
-                                        <p:tgtEl>
-                                          <p:spTgt spid="2">
-                                            <p:txEl>
-                                              <p:pRg st="4" end="4"/>
-                                            </p:txEl>
-                                          </p:spTgt>
-                                        </p:tgtEl>
-                                      </p:cBhvr>
-                                    </p:animEffect>
-                                  </p:childTnLst>
-                                </p:cTn>
-                              </p:par>
-                              <p:par>
-                                <p:cTn id="20" presetID="53" presetClass="entr" presetSubtype="16" fill="hold" nodeType="withEffect">
-                                  <p:stCondLst>
-                                    <p:cond delay="0"/>
-                                  </p:stCondLst>
-                                  <p:childTnLst>
-                                    <p:set>
-                                      <p:cBhvr>
-                                        <p:cTn id="21" dur="1" fill="hold">
-                                          <p:stCondLst>
-                                            <p:cond delay="0"/>
-                                          </p:stCondLst>
-                                        </p:cTn>
-                                        <p:tgtEl>
-                                          <p:spTgt spid="2">
-                                            <p:txEl>
-                                              <p:pRg st="6" end="6"/>
-                                            </p:txEl>
-                                          </p:spTgt>
-                                        </p:tgtEl>
-                                        <p:attrNameLst>
-                                          <p:attrName>style.visibility</p:attrName>
-                                        </p:attrNameLst>
-                                      </p:cBhvr>
-                                      <p:to>
-                                        <p:strVal val="visible"/>
-                                      </p:to>
-                                    </p:set>
-                                    <p:anim calcmode="lin" valueType="num">
-                                      <p:cBhvr>
-                                        <p:cTn id="22" dur="500" fill="hold"/>
-                                        <p:tgtEl>
-                                          <p:spTgt spid="2">
-                                            <p:txEl>
-                                              <p:pRg st="6" end="6"/>
-                                            </p:txEl>
-                                          </p:spTgt>
-                                        </p:tgtEl>
-                                        <p:attrNameLst>
-                                          <p:attrName>ppt_w</p:attrName>
-                                        </p:attrNameLst>
-                                      </p:cBhvr>
-                                      <p:tavLst>
-                                        <p:tav tm="0">
-                                          <p:val>
-                                            <p:fltVal val="0"/>
-                                          </p:val>
-                                        </p:tav>
-                                        <p:tav tm="100000">
-                                          <p:val>
-                                            <p:strVal val="#ppt_w"/>
-                                          </p:val>
-                                        </p:tav>
-                                      </p:tavLst>
-                                    </p:anim>
-                                    <p:anim calcmode="lin" valueType="num">
-                                      <p:cBhvr>
-                                        <p:cTn id="23" dur="500" fill="hold"/>
-                                        <p:tgtEl>
-                                          <p:spTgt spid="2">
-                                            <p:txEl>
-                                              <p:pRg st="6" end="6"/>
-                                            </p:txEl>
-                                          </p:spTgt>
-                                        </p:tgtEl>
-                                        <p:attrNameLst>
-                                          <p:attrName>ppt_h</p:attrName>
-                                        </p:attrNameLst>
-                                      </p:cBhvr>
-                                      <p:tavLst>
-                                        <p:tav tm="0">
-                                          <p:val>
-                                            <p:fltVal val="0"/>
-                                          </p:val>
-                                        </p:tav>
-                                        <p:tav tm="100000">
-                                          <p:val>
-                                            <p:strVal val="#ppt_h"/>
-                                          </p:val>
-                                        </p:tav>
-                                      </p:tavLst>
-                                    </p:anim>
-                                    <p:animEffect transition="in" filter="fade">
-                                      <p:cBhvr>
-                                        <p:cTn id="24" dur="500"/>
-                                        <p:tgtEl>
-                                          <p:spTgt spid="2">
-                                            <p:txEl>
-                                              <p:pRg st="6" end="6"/>
-                                            </p:txEl>
-                                          </p:spTgt>
-                                        </p:tgtEl>
-                                      </p:cBhvr>
-                                    </p:animEffect>
-                                  </p:childTnLst>
-                                </p:cTn>
-                              </p:par>
-                              <p:par>
-                                <p:cTn id="25" presetID="53" presetClass="entr" presetSubtype="16" fill="hold" nodeType="withEffect">
-                                  <p:stCondLst>
-                                    <p:cond delay="0"/>
-                                  </p:stCondLst>
-                                  <p:childTnLst>
-                                    <p:set>
-                                      <p:cBhvr>
-                                        <p:cTn id="26" dur="1" fill="hold">
-                                          <p:stCondLst>
-                                            <p:cond delay="0"/>
-                                          </p:stCondLst>
-                                        </p:cTn>
-                                        <p:tgtEl>
-                                          <p:spTgt spid="2">
-                                            <p:txEl>
-                                              <p:pRg st="8" end="8"/>
-                                            </p:txEl>
-                                          </p:spTgt>
-                                        </p:tgtEl>
-                                        <p:attrNameLst>
-                                          <p:attrName>style.visibility</p:attrName>
-                                        </p:attrNameLst>
-                                      </p:cBhvr>
-                                      <p:to>
-                                        <p:strVal val="visible"/>
-                                      </p:to>
-                                    </p:set>
-                                    <p:anim calcmode="lin" valueType="num">
-                                      <p:cBhvr>
-                                        <p:cTn id="27" dur="500" fill="hold"/>
-                                        <p:tgtEl>
-                                          <p:spTgt spid="2">
-                                            <p:txEl>
-                                              <p:pRg st="8" end="8"/>
-                                            </p:txEl>
-                                          </p:spTgt>
-                                        </p:tgtEl>
-                                        <p:attrNameLst>
-                                          <p:attrName>ppt_w</p:attrName>
-                                        </p:attrNameLst>
-                                      </p:cBhvr>
-                                      <p:tavLst>
-                                        <p:tav tm="0">
-                                          <p:val>
-                                            <p:fltVal val="0"/>
-                                          </p:val>
-                                        </p:tav>
-                                        <p:tav tm="100000">
-                                          <p:val>
-                                            <p:strVal val="#ppt_w"/>
-                                          </p:val>
-                                        </p:tav>
-                                      </p:tavLst>
-                                    </p:anim>
-                                    <p:anim calcmode="lin" valueType="num">
-                                      <p:cBhvr>
-                                        <p:cTn id="28" dur="500" fill="hold"/>
-                                        <p:tgtEl>
-                                          <p:spTgt spid="2">
-                                            <p:txEl>
-                                              <p:pRg st="8" end="8"/>
-                                            </p:txEl>
-                                          </p:spTgt>
-                                        </p:tgtEl>
-                                        <p:attrNameLst>
-                                          <p:attrName>ppt_h</p:attrName>
-                                        </p:attrNameLst>
-                                      </p:cBhvr>
-                                      <p:tavLst>
-                                        <p:tav tm="0">
-                                          <p:val>
-                                            <p:fltVal val="0"/>
-                                          </p:val>
-                                        </p:tav>
-                                        <p:tav tm="100000">
-                                          <p:val>
-                                            <p:strVal val="#ppt_h"/>
-                                          </p:val>
-                                        </p:tav>
-                                      </p:tavLst>
-                                    </p:anim>
-                                    <p:animEffect transition="in" filter="fade">
-                                      <p:cBhvr>
-                                        <p:cTn id="29" dur="500"/>
-                                        <p:tgtEl>
-                                          <p:spTgt spid="2">
-                                            <p:txEl>
-                                              <p:pRg st="8" end="8"/>
-                                            </p:txEl>
-                                          </p:spTgt>
-                                        </p:tgtEl>
-                                      </p:cBhvr>
-                                    </p:animEffect>
-                                  </p:childTnLst>
-                                </p:cTn>
-                              </p:par>
-                            </p:childTnLst>
-                          </p:cTn>
-                        </p:par>
-                      </p:childTnLst>
-                    </p:cTn>
-                  </p:par>
-                </p:childTnLst>
-              </p:cTn>
-              <p:prevCondLst>
-                <p:cond evt="onPrev" delay="0">
-                  <p:tgtEl>
-                    <p:sldTgt/>
-                  </p:tgtEl>
-                </p:cond>
-              </p:prevCondLst>
-              <p:nextCondLst>
-                <p:cond evt="onNext" delay="0">
-                  <p:tgtEl>
-                    <p:sldTgt/>
-                  </p:tgtEl>
-                </p:cond>
-              </p:nextCondLst>
-            </p:seq>
-          </p:childTnLst>
-        </p:cTn>
-      </p:par>
-    </p:tnLst>
-  </p:timing>
 </p:sld>
 </file>
 
 <file path=ppt/slides/slide8.xml><?xml version="1.0" encoding="utf-8"?>
+<p:sld xmlns:a="http://schemas.openxmlformats.org/drawingml/2006/main" xmlns:r="http://schemas.openxmlformats.org/officeDocument/2006/relationships" xmlns:p="http://schemas.openxmlformats.org/presentationml/2006/main">
+  <p:cSld>
+    <p:spTree>
+      <p:nvGrpSpPr>
+        <p:cNvPr id="1" name=""/>
+        <p:cNvGrpSpPr/>
+        <p:nvPr/>
+      </p:nvGrpSpPr>
+      <p:grpSpPr>
+        <a:xfrm>
+          <a:off x="0" y="0"/>
+          <a:ext cx="0" cy="0"/>
+          <a:chOff x="0" y="0"/>
+          <a:chExt cx="0" cy="0"/>
+        </a:xfrm>
+      </p:grpSpPr>
+      <p:pic>
+        <p:nvPicPr>
+          <p:cNvPr id="2" name="Picture 1"/>
+          <p:cNvPicPr>
+            <a:picLocks noChangeAspect="1"/>
+          </p:cNvPicPr>
+          <p:nvPr/>
+        </p:nvPicPr>
+        <p:blipFill>
+          <a:blip r:embed="rId2">
+            <a:extLst>
+              <a:ext uri="{28A0092B-C50C-407E-A947-70E740481C1C}">
+                <a14:useLocalDpi xmlns:a14="http://schemas.microsoft.com/office/drawing/2010/main" val="0"/>
+              </a:ext>
+            </a:extLst>
+          </a:blip>
+          <a:stretch>
+            <a:fillRect/>
+          </a:stretch>
+        </p:blipFill>
+        <p:spPr>
+          <a:xfrm>
+            <a:off x="0" y="0"/>
+            <a:ext cx="12192000" cy="6858000"/>
+          </a:xfrm>
+          <a:prstGeom prst="rect">
+            <a:avLst/>
+          </a:prstGeom>
+        </p:spPr>
+      </p:pic>
+    </p:spTree>
+    <p:extLst>
+      <p:ext uri="{BB962C8B-B14F-4D97-AF65-F5344CB8AC3E}">
+        <p14:creationId xmlns:p14="http://schemas.microsoft.com/office/powerpoint/2010/main" val="62763831"/>
+      </p:ext>
+    </p:extLst>
+  </p:cSld>
+  <p:clrMapOvr>
+    <a:masterClrMapping/>
+  </p:clrMapOvr>
+</p:sld>
+</file>
+
+<file path=ppt/slides/slide9.xml><?xml version="1.0" encoding="utf-8"?>
 <p:sld xmlns:a="http://schemas.openxmlformats.org/drawingml/2006/main" xmlns:r="http://schemas.openxmlformats.org/officeDocument/2006/relationships" xmlns:p="http://schemas.openxmlformats.org/presentationml/2006/main">
   <p:cSld>
     <p:spTree>
@@ -7488,8 +7685,8 @@
         </p:nvSpPr>
         <p:spPr>
           <a:xfrm>
-            <a:off x="2637692" y="1907931"/>
-            <a:ext cx="7728438" cy="1569660"/>
+            <a:off x="958362" y="1723292"/>
+            <a:ext cx="8598877" cy="3416320"/>
           </a:xfrm>
           <a:prstGeom prst="rect">
             <a:avLst/>
@@ -7503,33 +7700,73 @@
           <a:lstStyle/>
           <a:p>
             <a:r>
-              <a:rPr lang="en-US" sz="9600" dirty="0" smtClean="0"/>
-              <a:t>THANK YOU</a:t>
-            </a:r>
-            <a:endParaRPr lang="en-IN" sz="9600" dirty="0"/>
+              <a:rPr lang="en-IN" sz="2400" dirty="0"/>
+              <a:t>===== MODEL ACCURACIES (R² Score) =====</a:t>
+            </a:r>
+          </a:p>
+          <a:p>
+            <a:r>
+              <a:rPr lang="en-IN" sz="2400" dirty="0"/>
+              <a:t>Linear Regression: 0.1511</a:t>
+            </a:r>
+          </a:p>
+          <a:p>
+            <a:r>
+              <a:rPr lang="en-IN" sz="2400" dirty="0"/>
+              <a:t>Random Forest: 0.9970</a:t>
+            </a:r>
+          </a:p>
+          <a:p>
+            <a:r>
+              <a:rPr lang="en-IN" sz="2400" dirty="0"/>
+              <a:t>Gradient Boosting: 0.9887</a:t>
+            </a:r>
+          </a:p>
+          <a:p>
+            <a:r>
+              <a:rPr lang="en-IN" sz="2400" dirty="0" err="1"/>
+              <a:t>XGBoost</a:t>
+            </a:r>
+            <a:r>
+              <a:rPr lang="en-IN" sz="2400" dirty="0"/>
+              <a:t>: 0.9838</a:t>
+            </a:r>
+          </a:p>
+          <a:p>
+            <a:endParaRPr lang="en-IN" sz="2400" dirty="0"/>
+          </a:p>
+          <a:p>
+            <a:r>
+              <a:rPr lang="en-IN" sz="2400" dirty="0"/>
+              <a:t>Best Model: Random Forest with Accuracy (R²): 0.9970</a:t>
+            </a:r>
+          </a:p>
+          <a:p>
+            <a:endParaRPr lang="en-IN" sz="2400" dirty="0"/>
+          </a:p>
+          <a:p>
+            <a:r>
+              <a:rPr lang="en-IN" sz="2400" dirty="0"/>
+              <a:t>Model saved as: </a:t>
+            </a:r>
+            <a:r>
+              <a:rPr lang="en-IN" sz="2400" dirty="0" err="1"/>
+              <a:t>best_aqi_model.pkl</a:t>
+            </a:r>
+            <a:endParaRPr lang="en-IN" sz="2400" dirty="0"/>
           </a:p>
         </p:txBody>
       </p:sp>
     </p:spTree>
     <p:extLst>
       <p:ext uri="{BB962C8B-B14F-4D97-AF65-F5344CB8AC3E}">
-        <p14:creationId xmlns:p14="http://schemas.microsoft.com/office/powerpoint/2010/main" val="2833710442"/>
+        <p14:creationId xmlns:p14="http://schemas.microsoft.com/office/powerpoint/2010/main" val="2345843093"/>
       </p:ext>
     </p:extLst>
   </p:cSld>
   <p:clrMapOvr>
     <a:masterClrMapping/>
   </p:clrMapOvr>
-  <p:transition spd="slow">
-    <p:wipe/>
-  </p:transition>
-  <p:timing>
-    <p:tnLst>
-      <p:par>
-        <p:cTn id="1" dur="indefinite" restart="never" nodeType="tmRoot"/>
-      </p:par>
-    </p:tnLst>
-  </p:timing>
 </p:sld>
 </file>
 

</xml_diff>